<commit_message>
handbook: test count 1,369 in the deck and docs
Co-Authored-By: Claude Fable 5.1 <noreply@anthropic.com>
Claude-Session: https://claude.ai/code/session_01DA5cmByyXTZsJjuyUviAya
</commit_message>
<xml_diff>
--- a/docs/handbook/sbmig-overview.pptx
+++ b/docs/handbook/sbmig-overview.pptx
@@ -132,7 +132,7 @@
   <p:extLst>
     <p:ext uri="{521415D9-36F7-43E2-AB2F-B90AF26B5E84}">
       <p14:sectionLst xmlns:p14="http://schemas.microsoft.com/office/powerpoint/2010/main">
-        <p14:section name="소개" id="{1f60e9ad-bf62-13ed-4db2-1140d3ca92ea}">
+        <p14:section name="소개" id="{3828c082-f6b5-4fa1-1c16-f06e6b07ae4e}">
           <p14:sldIdLst>
             <p14:sldId id="256"/>
             <p14:sldId id="257"/>
@@ -140,7 +140,7 @@
             <p14:sldId id="259"/>
           </p14:sldIdLst>
         </p14:section>
-        <p14:section name="동작 원리" id="{57671406-8bc7-3db0-f106-06e4ee176fa3}">
+        <p14:section name="동작 원리" id="{7fe38fe9-fefd-6d13-ba20-3b8c2d719aa3}">
           <p14:sldIdLst>
             <p14:sldId id="260"/>
             <p14:sldId id="261"/>
@@ -151,7 +151,7 @@
             <p14:sldId id="266"/>
           </p14:sldIdLst>
         </p14:section>
-        <p14:section name="회사 레이아웃" id="{969f48fb-f9fe-a524-3739-1a5d9f12b952}">
+        <p14:section name="회사 레이아웃" id="{5c4a42cb-4cb7-cdd3-63d6-d5f1a1d91ee5}">
           <p14:sldIdLst>
             <p14:sldId id="267"/>
             <p14:sldId id="268"/>
@@ -159,7 +159,7 @@
             <p14:sldId id="270"/>
           </p14:sldIdLst>
         </p14:section>
-        <p14:section name="아키텍처" id="{84d03f09-f4ad-3381-9d63-173680274ab1}">
+        <p14:section name="아키텍처" id="{56d69062-f3a6-02f9-41ee-496cd48c1497}">
           <p14:sldIdLst>
             <p14:sldId id="271"/>
             <p14:sldId id="272"/>
@@ -167,7 +167,7 @@
             <p14:sldId id="274"/>
           </p14:sldIdLst>
         </p14:section>
-        <p14:section name="운영" id="{d9c47975-5d8f-cc87-4b0c-0487f845feb6}">
+        <p14:section name="운영" id="{33d2aee3-6fc3-11da-5b86-0192db2f4568}">
           <p14:sldIdLst>
             <p14:sldId id="275"/>
             <p14:sldId id="276"/>
@@ -175,7 +175,7 @@
             <p14:sldId id="278"/>
           </p14:sldIdLst>
         </p14:section>
-        <p14:section name="현황과 다음 단계" id="{e1ec257b-936c-ccfd-48a1-b227d290ad3c}">
+        <p14:section name="현황과 다음 단계" id="{882ed8d2-3754-4004-42de-74ee167d7164}">
           <p14:sldIdLst>
             <p14:sldId id="279"/>
             <p14:sldId id="280"/>
@@ -339,7 +339,7 @@
                   <c:v>1295</c:v>
                 </c:pt>
                 <c:pt idx="7">
-                  <c:v>1328</c:v>
+                  <c:v>1369</c:v>
                 </c:pt>
               </c:numCache>
             </c:numRef>
@@ -17185,7 +17185,7 @@
                   <a:schemeClr val="accent1"/>
                 </a:solidFill>
               </a:rPr>
-              <a:t>1,328</a:t>
+              <a:t>1,369</a:t>
             </a:r>
             <a:endParaRPr lang="en-US" sz="3800" dirty="0"/>
           </a:p>

</xml_diff>